<commit_message>
Garantizar la impugnación incluida sin filtro previo de viabilidad
Co-Authored-By: Claude Opus 5.5 <noreply@anthropic.com>
Claude-Session: https://claude.ai/code/session_01QAe3YyGWhdhctfhZWNy5HL
</commit_message>
<xml_diff>
--- a/jurix-global/presentacion-plan-ruta-segura.pptx
+++ b/jurix-global/presentacion-plan-ruta-segura.pptx
@@ -116,32 +116,32 @@
   <p:extLst>
     <p:ext uri="{521415D9-36F7-43E2-AB2F-B90AF26B5E84}">
       <p14:sectionLst xmlns:p14="http://schemas.microsoft.com/office/powerpoint/2010/main">
-        <p14:section name="Apertura" id="{58b5fe3e-0670-1491-5054-4d3f4a4d8519}">
+        <p14:section name="Apertura" id="{55102236-e2c6-1c23-e59e-8d05ff847e3d}">
           <p14:sldIdLst>
             <p14:sldId id="256"/>
           </p14:sldIdLst>
         </p14:section>
-        <p14:section name="El problema" id="{59440dac-7ee1-7a72-5033-e89602ad8a8b}">
+        <p14:section name="El problema" id="{1dc95639-ac98-4d55-7373-f3bfc8536da8}">
           <p14:sldIdLst>
             <p14:sldId id="257"/>
             <p14:sldId id="258"/>
           </p14:sldIdLst>
         </p14:section>
-        <p14:section name="La solución" id="{82dcc212-caad-d564-1eef-dfb198b5bd14}">
+        <p14:section name="La solución" id="{bfc0fa51-c9df-5861-a074-60139f37f3f9}">
           <p14:sldIdLst>
             <p14:sldId id="259"/>
             <p14:sldId id="260"/>
             <p14:sldId id="261"/>
           </p14:sldIdLst>
         </p14:section>
-        <p14:section name="Inversión" id="{b56e07d5-5fda-2092-2a5e-5a625a0bd301}">
+        <p14:section name="Inversión" id="{4b145de3-2ba0-0a97-b402-bb6ee721f720}">
           <p14:sldIdLst>
             <p14:sldId id="262"/>
             <p14:sldId id="263"/>
             <p14:sldId id="264"/>
           </p14:sldIdLst>
         </p14:section>
-        <p14:section name="Próximos pasos" id="{550c3556-71fa-4cdd-bbc9-ae3e6aeff60e}">
+        <p14:section name="Próximos pasos" id="{f4cb008f-46a6-205b-44de-c9308e03409b}">
           <p14:sldIdLst>
             <p14:sldId id="265"/>
           </p14:sldIdLst>
@@ -990,7 +990,7 @@
           <a:p>
             <a:r>
               <a:rPr lang="en-US" dirty="0"/>
-              <a:t>Recalque que el plazo legal es de 3 días. El compromiso del socio es enviarnos la citación dentro de 24 horas.</a:t>
+              <a:t>Recalque que el plazo legal es de 3 días. El compromiso del socio es enviarnos la citación dentro de 24 horas. Toda citación recibida a tiempo se impugna: la decisión la toma el juez, no el estudio.</a:t>
             </a:r>
             <a:endParaRPr lang="en-US" dirty="0"/>
           </a:p>
@@ -4169,7 +4169,7 @@
                   <a:schemeClr val="tx1"/>
                 </a:solidFill>
               </a:rPr>
-              <a:t>Una impugnación por bus al año, cuando sea jurídicamente viable.</a:t>
+              <a:t>Una impugnación por bus al año, garantizada. La defendemos y el juez decide.</a:t>
             </a:r>
             <a:endParaRPr lang="en-US" sz="1400" dirty="0"/>
           </a:p>
@@ -4827,7 +4827,7 @@
                   <a:schemeClr val="tx2"/>
                 </a:solidFill>
               </a:rPr>
-              <a:t>2. Evaluamos</a:t>
+              <a:t>2. Preparamos</a:t>
             </a:r>
             <a:endParaRPr lang="en-US" sz="1700" dirty="0"/>
           </a:p>
@@ -4863,7 +4863,7 @@
                   <a:schemeClr val="tx1"/>
                 </a:solidFill>
               </a:rPr>
-              <a:t>Revisamos si hay fundamentos para impugnar y le explicamos.</a:t>
+              <a:t>Armamos la defensa con las pruebas y le explicamos la estrategia.</a:t>
             </a:r>
             <a:endParaRPr lang="en-US" sz="1400" dirty="0"/>
           </a:p>

</xml_diff>

<commit_message>
Subir la asesoría a USD 400 en la versión original de la presentación
Co-Authored-By: Claude Opus 5.5 <noreply@anthropic.com>
Claude-Session: https://claude.ai/code/session_01QAe3YyGWhdhctfhZWNy5HL
</commit_message>
<xml_diff>
--- a/jurix-global/presentacion-plan-ruta-segura.pptx
+++ b/jurix-global/presentacion-plan-ruta-segura.pptx
@@ -116,32 +116,32 @@
   <p:extLst>
     <p:ext uri="{521415D9-36F7-43E2-AB2F-B90AF26B5E84}">
       <p14:sectionLst xmlns:p14="http://schemas.microsoft.com/office/powerpoint/2010/main">
-        <p14:section name="Apertura" id="{55102236-e2c6-1c23-e59e-8d05ff847e3d}">
+        <p14:section name="Apertura" id="{e51ab47e-52de-9edc-4d85-29e4ca82bfbc}">
           <p14:sldIdLst>
             <p14:sldId id="256"/>
           </p14:sldIdLst>
         </p14:section>
-        <p14:section name="El problema" id="{1dc95639-ac98-4d55-7373-f3bfc8536da8}">
+        <p14:section name="El problema" id="{1e2c5385-da60-3666-ef11-ea14ec1cdc4c}">
           <p14:sldIdLst>
             <p14:sldId id="257"/>
             <p14:sldId id="258"/>
           </p14:sldIdLst>
         </p14:section>
-        <p14:section name="La solución" id="{bfc0fa51-c9df-5861-a074-60139f37f3f9}">
+        <p14:section name="La solución" id="{04e8929f-5a33-b95b-2d83-389e6fa80ca2}">
           <p14:sldIdLst>
             <p14:sldId id="259"/>
             <p14:sldId id="260"/>
             <p14:sldId id="261"/>
           </p14:sldIdLst>
         </p14:section>
-        <p14:section name="Inversión" id="{4b145de3-2ba0-0a97-b402-bb6ee721f720}">
+        <p14:section name="Inversión" id="{2ea68adf-0ddb-cfc0-f143-dc41f9f7acbf}">
           <p14:sldIdLst>
             <p14:sldId id="262"/>
             <p14:sldId id="263"/>
             <p14:sldId id="264"/>
           </p14:sldIdLst>
         </p14:section>
-        <p14:section name="Próximos pasos" id="{f4cb008f-46a6-205b-44de-c9308e03409b}">
+        <p14:section name="Próximos pasos" id="{4a17a658-d334-2a46-f187-7f3b162bfdaa}">
           <p14:sldIdLst>
             <p14:sldId id="265"/>
           </p14:sldIdLst>
@@ -1166,7 +1166,7 @@
           <a:p>
             <a:r>
               <a:rPr lang="en-US" dirty="0"/>
-              <a:t>Haga la cuenta con el número real de buses de la cooperativa. Precios sin IVA.</a:t>
+              <a:t>Haga la cuenta con el número real de buses de la cooperativa. Precios sin IVA. Descuento de reserva (no está escrito en la presentación): si dudan, la asesoría puede quedar en USD 300 al contratar también el plan de buses. Úselo solo al final.</a:t>
             </a:r>
             <a:endParaRPr lang="en-US" dirty="0"/>
           </a:p>
@@ -6059,7 +6059,7 @@
                 <a:ea typeface="Cambria" pitchFamily="34" charset="-122"/>
                 <a:cs typeface="Cambria" pitchFamily="34" charset="-120"/>
               </a:rPr>
-              <a:t>USD 300</a:t>
+              <a:t>USD 400</a:t>
             </a:r>
             <a:endParaRPr lang="en-US" sz="3400" dirty="0"/>
           </a:p>
@@ -6481,7 +6481,7 @@
                   <a:schemeClr val="tx1"/>
                 </a:solidFill>
               </a:rPr>
-              <a:t>una cooperativa de 40 buses invierte USD 700 al mes. Son USD 17,50 por socio: menos de USD 0,60 al día.</a:t>
+              <a:t>una cooperativa de 40 buses invierte USD 800 al mes. Son USD 20 por socio: unos USD 0,67 al día.</a:t>
             </a:r>
             <a:endParaRPr lang="en-US" sz="1600" dirty="0"/>
           </a:p>

</xml_diff>